<commit_message>
Improvise RAG: Add Streamlit Web App, optimize pipeline with incremental processing, and add robust error checks
</commit_message>
<xml_diff>
--- a/RAG_AI_Teaching_Assistant_Presentation_v2.pptx
+++ b/RAG_AI_Teaching_Assistant_Presentation_v2.pptx
@@ -5,18 +5,18 @@
     <p:sldMasterId id="2147483648" r:id="rId1"/>
   </p:sldMasterIdLst>
   <p:sldIdLst>
-    <p:sldId id="256" r:id="rId7"/>
-    <p:sldId id="257" r:id="rId8"/>
-    <p:sldId id="258" r:id="rId9"/>
-    <p:sldId id="259" r:id="rId10"/>
-    <p:sldId id="260" r:id="rId11"/>
-    <p:sldId id="261" r:id="rId12"/>
-    <p:sldId id="262" r:id="rId13"/>
-    <p:sldId id="263" r:id="rId14"/>
-    <p:sldId id="264" r:id="rId15"/>
-    <p:sldId id="265" r:id="rId16"/>
+    <p:sldId id="256" r:id="rId2"/>
+    <p:sldId id="257" r:id="rId3"/>
+    <p:sldId id="258" r:id="rId4"/>
+    <p:sldId id="259" r:id="rId5"/>
+    <p:sldId id="260" r:id="rId6"/>
+    <p:sldId id="261" r:id="rId7"/>
+    <p:sldId id="262" r:id="rId8"/>
+    <p:sldId id="263" r:id="rId9"/>
+    <p:sldId id="264" r:id="rId10"/>
+    <p:sldId id="265" r:id="rId11"/>
   </p:sldIdLst>
-  <p:sldSz cx="12191695" cy="6858000" type="screen4x3"/>
+  <p:sldSz cx="12192000" cy="6858000"/>
   <p:notesSz cx="6858000" cy="9144000"/>
   <p:defaultTextStyle>
     <a:defPPr>
@@ -113,6 +113,22 @@
       </a:defRPr>
     </a:lvl9pPr>
   </p:defaultTextStyle>
+  <p:extLst>
+    <p:ext uri="{EFAFB233-063F-42B5-8137-9DF3F51BA10A}">
+      <p15:sldGuideLst xmlns:p15="http://schemas.microsoft.com/office/powerpoint/2012/main">
+        <p15:guide id="1" orient="horz" pos="2160">
+          <p15:clr>
+            <a:srgbClr val="A4A3A4"/>
+          </p15:clr>
+        </p15:guide>
+        <p15:guide id="2" pos="2880">
+          <p15:clr>
+            <a:srgbClr val="A4A3A4"/>
+          </p15:clr>
+        </p15:guide>
+      </p15:sldGuideLst>
+    </p:ext>
+  </p:extLst>
 </p:presentation>
 </file>
 
@@ -154,10 +170,9 @@
           <a:lstStyle/>
           <a:p>
             <a:r>
-              <a:rPr lang="en-US" smtClean="0"/>
+              <a:rPr lang="en-US"/>
               <a:t>Click to edit Master title style</a:t>
             </a:r>
-            <a:endParaRPr lang="en-US"/>
           </a:p>
         </p:txBody>
       </p:sp>
@@ -273,10 +288,9 @@
           </a:lstStyle>
           <a:p>
             <a:r>
-              <a:rPr lang="en-US" smtClean="0"/>
+              <a:rPr lang="en-US"/>
               <a:t>Click to edit Master subtitle style</a:t>
             </a:r>
-            <a:endParaRPr lang="en-US"/>
           </a:p>
         </p:txBody>
       </p:sp>
@@ -297,7 +311,7 @@
           <a:p>
             <a:fld id="{5BCAD085-E8A6-8845-BD4E-CB4CCA059FC4}" type="datetimeFigureOut">
               <a:rPr lang="en-US" smtClean="0"/>
-              <a:t>1/27/13</a:t>
+              <a:t>5/23/2026</a:t>
             </a:fld>
             <a:endParaRPr lang="en-US"/>
           </a:p>
@@ -391,10 +405,9 @@
           <a:lstStyle/>
           <a:p>
             <a:r>
-              <a:rPr lang="en-US" smtClean="0"/>
+              <a:rPr lang="en-US"/>
               <a:t>Click to edit Master title style</a:t>
             </a:r>
-            <a:endParaRPr lang="en-US"/>
           </a:p>
         </p:txBody>
       </p:sp>
@@ -415,38 +428,37 @@
           <a:p>
             <a:pPr lvl="0"/>
             <a:r>
-              <a:rPr lang="en-US" smtClean="0"/>
+              <a:rPr lang="en-US"/>
               <a:t>Click to edit Master text styles</a:t>
             </a:r>
           </a:p>
           <a:p>
             <a:pPr lvl="1"/>
             <a:r>
-              <a:rPr lang="en-US" smtClean="0"/>
+              <a:rPr lang="en-US"/>
               <a:t>Second level</a:t>
             </a:r>
           </a:p>
           <a:p>
             <a:pPr lvl="2"/>
             <a:r>
-              <a:rPr lang="en-US" smtClean="0"/>
+              <a:rPr lang="en-US"/>
               <a:t>Third level</a:t>
             </a:r>
           </a:p>
           <a:p>
             <a:pPr lvl="3"/>
             <a:r>
-              <a:rPr lang="en-US" smtClean="0"/>
+              <a:rPr lang="en-US"/>
               <a:t>Fourth level</a:t>
             </a:r>
           </a:p>
           <a:p>
             <a:pPr lvl="4"/>
             <a:r>
-              <a:rPr lang="en-US" smtClean="0"/>
+              <a:rPr lang="en-US"/>
               <a:t>Fifth level</a:t>
             </a:r>
-            <a:endParaRPr lang="en-US"/>
           </a:p>
         </p:txBody>
       </p:sp>
@@ -467,7 +479,7 @@
           <a:p>
             <a:fld id="{5BCAD085-E8A6-8845-BD4E-CB4CCA059FC4}" type="datetimeFigureOut">
               <a:rPr lang="en-US" smtClean="0"/>
-              <a:t>1/27/13</a:t>
+              <a:t>5/23/2026</a:t>
             </a:fld>
             <a:endParaRPr lang="en-US"/>
           </a:p>
@@ -566,10 +578,9 @@
           <a:lstStyle/>
           <a:p>
             <a:r>
-              <a:rPr lang="en-US" smtClean="0"/>
+              <a:rPr lang="en-US"/>
               <a:t>Click to edit Master title style</a:t>
             </a:r>
-            <a:endParaRPr lang="en-US"/>
           </a:p>
         </p:txBody>
       </p:sp>
@@ -595,38 +606,37 @@
           <a:p>
             <a:pPr lvl="0"/>
             <a:r>
-              <a:rPr lang="en-US" smtClean="0"/>
+              <a:rPr lang="en-US"/>
               <a:t>Click to edit Master text styles</a:t>
             </a:r>
           </a:p>
           <a:p>
             <a:pPr lvl="1"/>
             <a:r>
-              <a:rPr lang="en-US" smtClean="0"/>
+              <a:rPr lang="en-US"/>
               <a:t>Second level</a:t>
             </a:r>
           </a:p>
           <a:p>
             <a:pPr lvl="2"/>
             <a:r>
-              <a:rPr lang="en-US" smtClean="0"/>
+              <a:rPr lang="en-US"/>
               <a:t>Third level</a:t>
             </a:r>
           </a:p>
           <a:p>
             <a:pPr lvl="3"/>
             <a:r>
-              <a:rPr lang="en-US" smtClean="0"/>
+              <a:rPr lang="en-US"/>
               <a:t>Fourth level</a:t>
             </a:r>
           </a:p>
           <a:p>
             <a:pPr lvl="4"/>
             <a:r>
-              <a:rPr lang="en-US" smtClean="0"/>
+              <a:rPr lang="en-US"/>
               <a:t>Fifth level</a:t>
             </a:r>
-            <a:endParaRPr lang="en-US"/>
           </a:p>
         </p:txBody>
       </p:sp>
@@ -647,7 +657,7 @@
           <a:p>
             <a:fld id="{5BCAD085-E8A6-8845-BD4E-CB4CCA059FC4}" type="datetimeFigureOut">
               <a:rPr lang="en-US" smtClean="0"/>
-              <a:t>1/27/13</a:t>
+              <a:t>5/23/2026</a:t>
             </a:fld>
             <a:endParaRPr lang="en-US"/>
           </a:p>
@@ -741,10 +751,9 @@
           <a:lstStyle/>
           <a:p>
             <a:r>
-              <a:rPr lang="en-US" smtClean="0"/>
+              <a:rPr lang="en-US"/>
               <a:t>Click to edit Master title style</a:t>
             </a:r>
-            <a:endParaRPr lang="en-US"/>
           </a:p>
         </p:txBody>
       </p:sp>
@@ -765,38 +774,37 @@
           <a:p>
             <a:pPr lvl="0"/>
             <a:r>
-              <a:rPr lang="en-US" smtClean="0"/>
+              <a:rPr lang="en-US"/>
               <a:t>Click to edit Master text styles</a:t>
             </a:r>
           </a:p>
           <a:p>
             <a:pPr lvl="1"/>
             <a:r>
-              <a:rPr lang="en-US" smtClean="0"/>
+              <a:rPr lang="en-US"/>
               <a:t>Second level</a:t>
             </a:r>
           </a:p>
           <a:p>
             <a:pPr lvl="2"/>
             <a:r>
-              <a:rPr lang="en-US" smtClean="0"/>
+              <a:rPr lang="en-US"/>
               <a:t>Third level</a:t>
             </a:r>
           </a:p>
           <a:p>
             <a:pPr lvl="3"/>
             <a:r>
-              <a:rPr lang="en-US" smtClean="0"/>
+              <a:rPr lang="en-US"/>
               <a:t>Fourth level</a:t>
             </a:r>
           </a:p>
           <a:p>
             <a:pPr lvl="4"/>
             <a:r>
-              <a:rPr lang="en-US" smtClean="0"/>
+              <a:rPr lang="en-US"/>
               <a:t>Fifth level</a:t>
             </a:r>
-            <a:endParaRPr lang="en-US"/>
           </a:p>
         </p:txBody>
       </p:sp>
@@ -817,7 +825,7 @@
           <a:p>
             <a:fld id="{5BCAD085-E8A6-8845-BD4E-CB4CCA059FC4}" type="datetimeFigureOut">
               <a:rPr lang="en-US" smtClean="0"/>
-              <a:t>1/27/13</a:t>
+              <a:t>5/23/2026</a:t>
             </a:fld>
             <a:endParaRPr lang="en-US"/>
           </a:p>
@@ -920,10 +928,9 @@
           </a:lstStyle>
           <a:p>
             <a:r>
-              <a:rPr lang="en-US" smtClean="0"/>
+              <a:rPr lang="en-US"/>
               <a:t>Click to edit Master title style</a:t>
             </a:r>
-            <a:endParaRPr lang="en-US"/>
           </a:p>
         </p:txBody>
       </p:sp>
@@ -1040,7 +1047,7 @@
           <a:p>
             <a:pPr lvl="0"/>
             <a:r>
-              <a:rPr lang="en-US" smtClean="0"/>
+              <a:rPr lang="en-US"/>
               <a:t>Click to edit Master text styles</a:t>
             </a:r>
           </a:p>
@@ -1063,7 +1070,7 @@
           <a:p>
             <a:fld id="{5BCAD085-E8A6-8845-BD4E-CB4CCA059FC4}" type="datetimeFigureOut">
               <a:rPr lang="en-US" smtClean="0"/>
-              <a:t>1/27/13</a:t>
+              <a:t>5/23/2026</a:t>
             </a:fld>
             <a:endParaRPr lang="en-US"/>
           </a:p>
@@ -1157,10 +1164,9 @@
           <a:lstStyle/>
           <a:p>
             <a:r>
-              <a:rPr lang="en-US" smtClean="0"/>
+              <a:rPr lang="en-US"/>
               <a:t>Click to edit Master title style</a:t>
             </a:r>
-            <a:endParaRPr lang="en-US"/>
           </a:p>
         </p:txBody>
       </p:sp>
@@ -1214,38 +1220,37 @@
           <a:p>
             <a:pPr lvl="0"/>
             <a:r>
-              <a:rPr lang="en-US" smtClean="0"/>
+              <a:rPr lang="en-US"/>
               <a:t>Click to edit Master text styles</a:t>
             </a:r>
           </a:p>
           <a:p>
             <a:pPr lvl="1"/>
             <a:r>
-              <a:rPr lang="en-US" smtClean="0"/>
+              <a:rPr lang="en-US"/>
               <a:t>Second level</a:t>
             </a:r>
           </a:p>
           <a:p>
             <a:pPr lvl="2"/>
             <a:r>
-              <a:rPr lang="en-US" smtClean="0"/>
+              <a:rPr lang="en-US"/>
               <a:t>Third level</a:t>
             </a:r>
           </a:p>
           <a:p>
             <a:pPr lvl="3"/>
             <a:r>
-              <a:rPr lang="en-US" smtClean="0"/>
+              <a:rPr lang="en-US"/>
               <a:t>Fourth level</a:t>
             </a:r>
           </a:p>
           <a:p>
             <a:pPr lvl="4"/>
             <a:r>
-              <a:rPr lang="en-US" smtClean="0"/>
+              <a:rPr lang="en-US"/>
               <a:t>Fifth level</a:t>
             </a:r>
-            <a:endParaRPr lang="en-US"/>
           </a:p>
         </p:txBody>
       </p:sp>
@@ -1299,38 +1304,37 @@
           <a:p>
             <a:pPr lvl="0"/>
             <a:r>
-              <a:rPr lang="en-US" smtClean="0"/>
+              <a:rPr lang="en-US"/>
               <a:t>Click to edit Master text styles</a:t>
             </a:r>
           </a:p>
           <a:p>
             <a:pPr lvl="1"/>
             <a:r>
-              <a:rPr lang="en-US" smtClean="0"/>
+              <a:rPr lang="en-US"/>
               <a:t>Second level</a:t>
             </a:r>
           </a:p>
           <a:p>
             <a:pPr lvl="2"/>
             <a:r>
-              <a:rPr lang="en-US" smtClean="0"/>
+              <a:rPr lang="en-US"/>
               <a:t>Third level</a:t>
             </a:r>
           </a:p>
           <a:p>
             <a:pPr lvl="3"/>
             <a:r>
-              <a:rPr lang="en-US" smtClean="0"/>
+              <a:rPr lang="en-US"/>
               <a:t>Fourth level</a:t>
             </a:r>
           </a:p>
           <a:p>
             <a:pPr lvl="4"/>
             <a:r>
-              <a:rPr lang="en-US" smtClean="0"/>
+              <a:rPr lang="en-US"/>
               <a:t>Fifth level</a:t>
             </a:r>
-            <a:endParaRPr lang="en-US"/>
           </a:p>
         </p:txBody>
       </p:sp>
@@ -1351,7 +1355,7 @@
           <a:p>
             <a:fld id="{5BCAD085-E8A6-8845-BD4E-CB4CCA059FC4}" type="datetimeFigureOut">
               <a:rPr lang="en-US" smtClean="0"/>
-              <a:t>1/27/13</a:t>
+              <a:t>5/23/2026</a:t>
             </a:fld>
             <a:endParaRPr lang="en-US"/>
           </a:p>
@@ -1449,10 +1453,9 @@
           </a:lstStyle>
           <a:p>
             <a:r>
-              <a:rPr lang="en-US" smtClean="0"/>
+              <a:rPr lang="en-US"/>
               <a:t>Click to edit Master title style</a:t>
             </a:r>
-            <a:endParaRPr lang="en-US"/>
           </a:p>
         </p:txBody>
       </p:sp>
@@ -1515,7 +1518,7 @@
           <a:p>
             <a:pPr lvl="0"/>
             <a:r>
-              <a:rPr lang="en-US" smtClean="0"/>
+              <a:rPr lang="en-US"/>
               <a:t>Click to edit Master text styles</a:t>
             </a:r>
           </a:p>
@@ -1571,38 +1574,37 @@
           <a:p>
             <a:pPr lvl="0"/>
             <a:r>
-              <a:rPr lang="en-US" smtClean="0"/>
+              <a:rPr lang="en-US"/>
               <a:t>Click to edit Master text styles</a:t>
             </a:r>
           </a:p>
           <a:p>
             <a:pPr lvl="1"/>
             <a:r>
-              <a:rPr lang="en-US" smtClean="0"/>
+              <a:rPr lang="en-US"/>
               <a:t>Second level</a:t>
             </a:r>
           </a:p>
           <a:p>
             <a:pPr lvl="2"/>
             <a:r>
-              <a:rPr lang="en-US" smtClean="0"/>
+              <a:rPr lang="en-US"/>
               <a:t>Third level</a:t>
             </a:r>
           </a:p>
           <a:p>
             <a:pPr lvl="3"/>
             <a:r>
-              <a:rPr lang="en-US" smtClean="0"/>
+              <a:rPr lang="en-US"/>
               <a:t>Fourth level</a:t>
             </a:r>
           </a:p>
           <a:p>
             <a:pPr lvl="4"/>
             <a:r>
-              <a:rPr lang="en-US" smtClean="0"/>
+              <a:rPr lang="en-US"/>
               <a:t>Fifth level</a:t>
             </a:r>
-            <a:endParaRPr lang="en-US"/>
           </a:p>
         </p:txBody>
       </p:sp>
@@ -1665,7 +1667,7 @@
           <a:p>
             <a:pPr lvl="0"/>
             <a:r>
-              <a:rPr lang="en-US" smtClean="0"/>
+              <a:rPr lang="en-US"/>
               <a:t>Click to edit Master text styles</a:t>
             </a:r>
           </a:p>
@@ -1721,38 +1723,37 @@
           <a:p>
             <a:pPr lvl="0"/>
             <a:r>
-              <a:rPr lang="en-US" smtClean="0"/>
+              <a:rPr lang="en-US"/>
               <a:t>Click to edit Master text styles</a:t>
             </a:r>
           </a:p>
           <a:p>
             <a:pPr lvl="1"/>
             <a:r>
-              <a:rPr lang="en-US" smtClean="0"/>
+              <a:rPr lang="en-US"/>
               <a:t>Second level</a:t>
             </a:r>
           </a:p>
           <a:p>
             <a:pPr lvl="2"/>
             <a:r>
-              <a:rPr lang="en-US" smtClean="0"/>
+              <a:rPr lang="en-US"/>
               <a:t>Third level</a:t>
             </a:r>
           </a:p>
           <a:p>
             <a:pPr lvl="3"/>
             <a:r>
-              <a:rPr lang="en-US" smtClean="0"/>
+              <a:rPr lang="en-US"/>
               <a:t>Fourth level</a:t>
             </a:r>
           </a:p>
           <a:p>
             <a:pPr lvl="4"/>
             <a:r>
-              <a:rPr lang="en-US" smtClean="0"/>
+              <a:rPr lang="en-US"/>
               <a:t>Fifth level</a:t>
             </a:r>
-            <a:endParaRPr lang="en-US"/>
           </a:p>
         </p:txBody>
       </p:sp>
@@ -1773,7 +1774,7 @@
           <a:p>
             <a:fld id="{5BCAD085-E8A6-8845-BD4E-CB4CCA059FC4}" type="datetimeFigureOut">
               <a:rPr lang="en-US" smtClean="0"/>
-              <a:t>1/27/13</a:t>
+              <a:t>5/23/2026</a:t>
             </a:fld>
             <a:endParaRPr lang="en-US"/>
           </a:p>
@@ -1867,10 +1868,9 @@
           <a:lstStyle/>
           <a:p>
             <a:r>
-              <a:rPr lang="en-US" smtClean="0"/>
+              <a:rPr lang="en-US"/>
               <a:t>Click to edit Master title style</a:t>
             </a:r>
-            <a:endParaRPr lang="en-US"/>
           </a:p>
         </p:txBody>
       </p:sp>
@@ -1891,7 +1891,7 @@
           <a:p>
             <a:fld id="{5BCAD085-E8A6-8845-BD4E-CB4CCA059FC4}" type="datetimeFigureOut">
               <a:rPr lang="en-US" smtClean="0"/>
-              <a:t>1/27/13</a:t>
+              <a:t>5/23/2026</a:t>
             </a:fld>
             <a:endParaRPr lang="en-US"/>
           </a:p>
@@ -1986,7 +1986,7 @@
           <a:p>
             <a:fld id="{5BCAD085-E8A6-8845-BD4E-CB4CCA059FC4}" type="datetimeFigureOut">
               <a:rPr lang="en-US" smtClean="0"/>
-              <a:t>1/27/13</a:t>
+              <a:t>5/23/2026</a:t>
             </a:fld>
             <a:endParaRPr lang="en-US"/>
           </a:p>
@@ -2089,10 +2089,9 @@
           </a:lstStyle>
           <a:p>
             <a:r>
-              <a:rPr lang="en-US" smtClean="0"/>
+              <a:rPr lang="en-US"/>
               <a:t>Click to edit Master title style</a:t>
             </a:r>
-            <a:endParaRPr lang="en-US"/>
           </a:p>
         </p:txBody>
       </p:sp>
@@ -2146,38 +2145,37 @@
           <a:p>
             <a:pPr lvl="0"/>
             <a:r>
-              <a:rPr lang="en-US" smtClean="0"/>
+              <a:rPr lang="en-US"/>
               <a:t>Click to edit Master text styles</a:t>
             </a:r>
           </a:p>
           <a:p>
             <a:pPr lvl="1"/>
             <a:r>
-              <a:rPr lang="en-US" smtClean="0"/>
+              <a:rPr lang="en-US"/>
               <a:t>Second level</a:t>
             </a:r>
           </a:p>
           <a:p>
             <a:pPr lvl="2"/>
             <a:r>
-              <a:rPr lang="en-US" smtClean="0"/>
+              <a:rPr lang="en-US"/>
               <a:t>Third level</a:t>
             </a:r>
           </a:p>
           <a:p>
             <a:pPr lvl="3"/>
             <a:r>
-              <a:rPr lang="en-US" smtClean="0"/>
+              <a:rPr lang="en-US"/>
               <a:t>Fourth level</a:t>
             </a:r>
           </a:p>
           <a:p>
             <a:pPr lvl="4"/>
             <a:r>
-              <a:rPr lang="en-US" smtClean="0"/>
+              <a:rPr lang="en-US"/>
               <a:t>Fifth level</a:t>
             </a:r>
-            <a:endParaRPr lang="en-US"/>
           </a:p>
         </p:txBody>
       </p:sp>
@@ -2240,7 +2238,7 @@
           <a:p>
             <a:pPr lvl="0"/>
             <a:r>
-              <a:rPr lang="en-US" smtClean="0"/>
+              <a:rPr lang="en-US"/>
               <a:t>Click to edit Master text styles</a:t>
             </a:r>
           </a:p>
@@ -2263,7 +2261,7 @@
           <a:p>
             <a:fld id="{5BCAD085-E8A6-8845-BD4E-CB4CCA059FC4}" type="datetimeFigureOut">
               <a:rPr lang="en-US" smtClean="0"/>
-              <a:t>1/27/13</a:t>
+              <a:t>5/23/2026</a:t>
             </a:fld>
             <a:endParaRPr lang="en-US"/>
           </a:p>
@@ -2366,10 +2364,9 @@
           </a:lstStyle>
           <a:p>
             <a:r>
-              <a:rPr lang="en-US" smtClean="0"/>
+              <a:rPr lang="en-US"/>
               <a:t>Click to edit Master title style</a:t>
             </a:r>
-            <a:endParaRPr lang="en-US"/>
           </a:p>
         </p:txBody>
       </p:sp>
@@ -2493,7 +2490,7 @@
           <a:p>
             <a:pPr lvl="0"/>
             <a:r>
-              <a:rPr lang="en-US" smtClean="0"/>
+              <a:rPr lang="en-US"/>
               <a:t>Click to edit Master text styles</a:t>
             </a:r>
           </a:p>
@@ -2516,7 +2513,7 @@
           <a:p>
             <a:fld id="{5BCAD085-E8A6-8845-BD4E-CB4CCA059FC4}" type="datetimeFigureOut">
               <a:rPr lang="en-US" smtClean="0"/>
-              <a:t>1/27/13</a:t>
+              <a:t>5/23/2026</a:t>
             </a:fld>
             <a:endParaRPr lang="en-US"/>
           </a:p>
@@ -2625,10 +2622,9 @@
           <a:lstStyle/>
           <a:p>
             <a:r>
-              <a:rPr lang="en-US" smtClean="0"/>
+              <a:rPr lang="en-US"/>
               <a:t>Click to edit Master title style</a:t>
             </a:r>
-            <a:endParaRPr lang="en-US"/>
           </a:p>
         </p:txBody>
       </p:sp>
@@ -2659,38 +2655,37 @@
           <a:p>
             <a:pPr lvl="0"/>
             <a:r>
-              <a:rPr lang="en-US" smtClean="0"/>
+              <a:rPr lang="en-US"/>
               <a:t>Click to edit Master text styles</a:t>
             </a:r>
           </a:p>
           <a:p>
             <a:pPr lvl="1"/>
             <a:r>
-              <a:rPr lang="en-US" smtClean="0"/>
+              <a:rPr lang="en-US"/>
               <a:t>Second level</a:t>
             </a:r>
           </a:p>
           <a:p>
             <a:pPr lvl="2"/>
             <a:r>
-              <a:rPr lang="en-US" smtClean="0"/>
+              <a:rPr lang="en-US"/>
               <a:t>Third level</a:t>
             </a:r>
           </a:p>
           <a:p>
             <a:pPr lvl="3"/>
             <a:r>
-              <a:rPr lang="en-US" smtClean="0"/>
+              <a:rPr lang="en-US"/>
               <a:t>Fourth level</a:t>
             </a:r>
           </a:p>
           <a:p>
             <a:pPr lvl="4"/>
             <a:r>
-              <a:rPr lang="en-US" smtClean="0"/>
+              <a:rPr lang="en-US"/>
               <a:t>Fifth level</a:t>
             </a:r>
-            <a:endParaRPr lang="en-US"/>
           </a:p>
         </p:txBody>
       </p:sp>
@@ -2729,7 +2724,7 @@
           <a:p>
             <a:fld id="{5BCAD085-E8A6-8845-BD4E-CB4CCA059FC4}" type="datetimeFigureOut">
               <a:rPr lang="en-US" smtClean="0"/>
-              <a:t>1/27/13</a:t>
+              <a:t>5/23/2026</a:t>
             </a:fld>
             <a:endParaRPr lang="en-US"/>
           </a:p>
@@ -3088,7 +3083,7 @@
 </file>
 
 <file path=ppt/slides/slide1.xml><?xml version="1.0" encoding="utf-8"?>
-<p:sld xmlns:a="http://schemas.openxmlformats.org/drawingml/2006/main" xmlns:p="http://schemas.openxmlformats.org/presentationml/2006/main" xmlns:r="http://schemas.openxmlformats.org/officeDocument/2006/relationships">
+<p:sld xmlns:a="http://schemas.openxmlformats.org/drawingml/2006/main" xmlns:r="http://schemas.openxmlformats.org/officeDocument/2006/relationships" xmlns:p="http://schemas.openxmlformats.org/presentationml/2006/main">
   <p:cSld>
     <p:bg>
       <p:bgPr>
@@ -3104,7 +3099,14 @@
         <p:cNvGrpSpPr/>
         <p:nvPr/>
       </p:nvGrpSpPr>
-      <p:grpSpPr/>
+      <p:grpSpPr>
+        <a:xfrm>
+          <a:off x="0" y="0"/>
+          <a:ext cx="0" cy="0"/>
+          <a:chOff x="0" y="0"/>
+          <a:chExt cx="0" cy="0"/>
+        </a:xfrm>
+      </p:grpSpPr>
       <p:sp>
         <p:nvSpPr>
           <p:cNvPr id="2" name="Rectangle 1"/>
@@ -3145,6 +3147,7 @@
           <a:lstStyle/>
           <a:p>
             <a:pPr algn="ctr"/>
+            <a:endParaRPr/>
           </a:p>
         </p:txBody>
       </p:sp>
@@ -3157,7 +3160,7 @@
         <p:spPr>
           <a:xfrm>
             <a:off x="1097280" y="1371600"/>
-            <a:ext cx="6400800" cy="4572000"/>
+            <a:ext cx="6400800" cy="2482731"/>
           </a:xfrm>
           <a:prstGeom prst="rect">
             <a:avLst/>
@@ -3182,6 +3185,7 @@
               </a:defRPr>
             </a:pPr>
             <a:r>
+              <a:rPr dirty="0"/>
               <a:t>DATA SCIENCE PROJECT SHOWCASE</a:t>
             </a:r>
           </a:p>
@@ -3198,10 +3202,14 @@
               </a:defRPr>
             </a:pPr>
             <a:r>
+              <a:rPr dirty="0"/>
               <a:t>RAG-Based AI</a:t>
             </a:r>
-            <a:br/>
-            <a:r>
+            <a:br>
+              <a:rPr dirty="0"/>
+            </a:br>
+            <a:r>
+              <a:rPr dirty="0"/>
               <a:t>Teaching Assistant</a:t>
             </a:r>
           </a:p>
@@ -3218,25 +3226,13 @@
               </a:defRPr>
             </a:pPr>
             <a:r>
-              <a:t>Local Video-to-Text Transcription, Semantic Search, and Q&amp;A System</a:t>
-            </a:r>
-          </a:p>
-          <a:p>
-            <a:pPr>
-              <a:defRPr sz="1200" i="1">
-                <a:solidFill>
-                  <a:srgbClr val="0EA5E9"/>
-                </a:solidFill>
-                <a:latin typeface="Arial"/>
-              </a:defRPr>
-            </a:pPr>
-            <a:r>
-              <a:t>Inspired by the Ultimate Job Ready Data Science Course</a:t>
-            </a:r>
-            <a:br/>
-            <a:r>
-              <a:t>(Code With Harry Project 3)</a:t>
-            </a:r>
+              <a:rPr dirty="0"/>
+              <a:t>Local Video-to-Text Transcription, Semantic Search, and Q&amp;</a:t>
+            </a:r>
+            <a:r>
+              <a:t>A System</a:t>
+            </a:r>
+            <a:endParaRPr dirty="0"/>
           </a:p>
         </p:txBody>
       </p:sp>
@@ -3282,6 +3278,7 @@
           <a:lstStyle/>
           <a:p>
             <a:pPr algn="ctr"/>
+            <a:endParaRPr/>
           </a:p>
         </p:txBody>
       </p:sp>
@@ -3449,7 +3446,7 @@
 </file>
 
 <file path=ppt/slides/slide10.xml><?xml version="1.0" encoding="utf-8"?>
-<p:sld xmlns:a="http://schemas.openxmlformats.org/drawingml/2006/main" xmlns:p="http://schemas.openxmlformats.org/presentationml/2006/main" xmlns:r="http://schemas.openxmlformats.org/officeDocument/2006/relationships">
+<p:sld xmlns:a="http://schemas.openxmlformats.org/drawingml/2006/main" xmlns:r="http://schemas.openxmlformats.org/officeDocument/2006/relationships" xmlns:p="http://schemas.openxmlformats.org/presentationml/2006/main">
   <p:cSld>
     <p:bg>
       <p:bgPr>
@@ -3465,7 +3462,14 @@
         <p:cNvGrpSpPr/>
         <p:nvPr/>
       </p:nvGrpSpPr>
-      <p:grpSpPr/>
+      <p:grpSpPr>
+        <a:xfrm>
+          <a:off x="0" y="0"/>
+          <a:ext cx="0" cy="0"/>
+          <a:chOff x="0" y="0"/>
+          <a:chExt cx="0" cy="0"/>
+        </a:xfrm>
+      </p:grpSpPr>
       <p:sp>
         <p:nvSpPr>
           <p:cNvPr id="2" name="Rectangle 1"/>
@@ -3506,6 +3510,7 @@
           <a:lstStyle/>
           <a:p>
             <a:pPr algn="ctr"/>
+            <a:endParaRPr/>
           </a:p>
         </p:txBody>
       </p:sp>
@@ -3737,7 +3742,7 @@
 </file>
 
 <file path=ppt/slides/slide2.xml><?xml version="1.0" encoding="utf-8"?>
-<p:sld xmlns:a="http://schemas.openxmlformats.org/drawingml/2006/main" xmlns:p="http://schemas.openxmlformats.org/presentationml/2006/main" xmlns:r="http://schemas.openxmlformats.org/officeDocument/2006/relationships">
+<p:sld xmlns:a="http://schemas.openxmlformats.org/drawingml/2006/main" xmlns:r="http://schemas.openxmlformats.org/officeDocument/2006/relationships" xmlns:p="http://schemas.openxmlformats.org/presentationml/2006/main">
   <p:cSld>
     <p:bg>
       <p:bgPr>
@@ -3753,7 +3758,14 @@
         <p:cNvGrpSpPr/>
         <p:nvPr/>
       </p:nvGrpSpPr>
-      <p:grpSpPr/>
+      <p:grpSpPr>
+        <a:xfrm>
+          <a:off x="0" y="0"/>
+          <a:ext cx="0" cy="0"/>
+          <a:chOff x="0" y="0"/>
+          <a:chExt cx="0" cy="0"/>
+        </a:xfrm>
+      </p:grpSpPr>
       <p:sp>
         <p:nvSpPr>
           <p:cNvPr id="2" name="TextBox 1"/>
@@ -3771,7 +3783,7 @@
           <a:noFill/>
         </p:spPr>
         <p:txBody>
-          <a:bodyPr wrap="square" lIns="0" rIns="0" tIns="0" bIns="0">
+          <a:bodyPr wrap="square" lIns="0" tIns="0" rIns="0" bIns="0">
             <a:spAutoFit/>
           </a:bodyPr>
           <a:lstStyle/>
@@ -3807,7 +3819,7 @@
           <a:noFill/>
         </p:spPr>
         <p:txBody>
-          <a:bodyPr wrap="square" lIns="0" rIns="0" tIns="0" bIns="0">
+          <a:bodyPr wrap="square" lIns="0" tIns="0" rIns="0" bIns="0">
             <a:spAutoFit/>
           </a:bodyPr>
           <a:lstStyle/>
@@ -3866,6 +3878,7 @@
           <a:lstStyle/>
           <a:p>
             <a:pPr algn="ctr"/>
+            <a:endParaRPr/>
           </a:p>
         </p:txBody>
       </p:sp>
@@ -4027,6 +4040,7 @@
           <a:lstStyle/>
           <a:p>
             <a:pPr algn="ctr"/>
+            <a:endParaRPr/>
           </a:p>
         </p:txBody>
       </p:sp>
@@ -4158,7 +4172,7 @@
 </file>
 
 <file path=ppt/slides/slide3.xml><?xml version="1.0" encoding="utf-8"?>
-<p:sld xmlns:a="http://schemas.openxmlformats.org/drawingml/2006/main" xmlns:p="http://schemas.openxmlformats.org/presentationml/2006/main" xmlns:r="http://schemas.openxmlformats.org/officeDocument/2006/relationships">
+<p:sld xmlns:a="http://schemas.openxmlformats.org/drawingml/2006/main" xmlns:r="http://schemas.openxmlformats.org/officeDocument/2006/relationships" xmlns:p="http://schemas.openxmlformats.org/presentationml/2006/main">
   <p:cSld>
     <p:bg>
       <p:bgPr>
@@ -4174,7 +4188,14 @@
         <p:cNvGrpSpPr/>
         <p:nvPr/>
       </p:nvGrpSpPr>
-      <p:grpSpPr/>
+      <p:grpSpPr>
+        <a:xfrm>
+          <a:off x="0" y="0"/>
+          <a:ext cx="0" cy="0"/>
+          <a:chOff x="0" y="0"/>
+          <a:chExt cx="0" cy="0"/>
+        </a:xfrm>
+      </p:grpSpPr>
       <p:sp>
         <p:nvSpPr>
           <p:cNvPr id="2" name="TextBox 1"/>
@@ -4192,7 +4213,7 @@
           <a:noFill/>
         </p:spPr>
         <p:txBody>
-          <a:bodyPr wrap="square" lIns="0" rIns="0" tIns="0" bIns="0">
+          <a:bodyPr wrap="square" lIns="0" tIns="0" rIns="0" bIns="0">
             <a:spAutoFit/>
           </a:bodyPr>
           <a:lstStyle/>
@@ -4228,7 +4249,7 @@
           <a:noFill/>
         </p:spPr>
         <p:txBody>
-          <a:bodyPr wrap="square" lIns="0" rIns="0" tIns="0" bIns="0">
+          <a:bodyPr wrap="square" lIns="0" tIns="0" rIns="0" bIns="0">
             <a:spAutoFit/>
           </a:bodyPr>
           <a:lstStyle/>
@@ -4287,6 +4308,7 @@
           <a:lstStyle/>
           <a:p>
             <a:pPr algn="ctr"/>
+            <a:endParaRPr/>
           </a:p>
         </p:txBody>
       </p:sp>
@@ -4451,6 +4473,7 @@
           <a:lstStyle/>
           <a:p>
             <a:pPr algn="ctr"/>
+            <a:endParaRPr/>
           </a:p>
         </p:txBody>
       </p:sp>
@@ -4471,7 +4494,7 @@
           <a:noFill/>
         </p:spPr>
         <p:txBody>
-          <a:bodyPr wrap="square" lIns="0" tIns="0" bIns="0" rIns="0">
+          <a:bodyPr wrap="square" lIns="0" tIns="0" rIns="0" bIns="0">
             <a:spAutoFit/>
           </a:bodyPr>
           <a:lstStyle/>
@@ -4548,6 +4571,7 @@
           <a:lstStyle/>
           <a:p>
             <a:pPr algn="ctr"/>
+            <a:endParaRPr/>
           </a:p>
         </p:txBody>
       </p:sp>
@@ -4568,7 +4592,7 @@
           <a:noFill/>
         </p:spPr>
         <p:txBody>
-          <a:bodyPr wrap="square" lIns="0" tIns="0" bIns="0" rIns="0">
+          <a:bodyPr wrap="square" lIns="0" tIns="0" rIns="0" bIns="0">
             <a:spAutoFit/>
           </a:bodyPr>
           <a:lstStyle/>
@@ -4645,6 +4669,7 @@
           <a:lstStyle/>
           <a:p>
             <a:pPr algn="ctr"/>
+            <a:endParaRPr/>
           </a:p>
         </p:txBody>
       </p:sp>
@@ -4665,7 +4690,7 @@
           <a:noFill/>
         </p:spPr>
         <p:txBody>
-          <a:bodyPr wrap="square" lIns="0" tIns="0" bIns="0" rIns="0">
+          <a:bodyPr wrap="square" lIns="0" tIns="0" rIns="0" bIns="0">
             <a:spAutoFit/>
           </a:bodyPr>
           <a:lstStyle/>
@@ -4709,7 +4734,7 @@
 </file>
 
 <file path=ppt/slides/slide4.xml><?xml version="1.0" encoding="utf-8"?>
-<p:sld xmlns:a="http://schemas.openxmlformats.org/drawingml/2006/main" xmlns:p="http://schemas.openxmlformats.org/presentationml/2006/main" xmlns:r="http://schemas.openxmlformats.org/officeDocument/2006/relationships">
+<p:sld xmlns:a="http://schemas.openxmlformats.org/drawingml/2006/main" xmlns:r="http://schemas.openxmlformats.org/officeDocument/2006/relationships" xmlns:p="http://schemas.openxmlformats.org/presentationml/2006/main">
   <p:cSld>
     <p:bg>
       <p:bgPr>
@@ -4725,7 +4750,14 @@
         <p:cNvGrpSpPr/>
         <p:nvPr/>
       </p:nvGrpSpPr>
-      <p:grpSpPr/>
+      <p:grpSpPr>
+        <a:xfrm>
+          <a:off x="0" y="0"/>
+          <a:ext cx="0" cy="0"/>
+          <a:chOff x="0" y="0"/>
+          <a:chExt cx="0" cy="0"/>
+        </a:xfrm>
+      </p:grpSpPr>
       <p:sp>
         <p:nvSpPr>
           <p:cNvPr id="2" name="TextBox 1"/>
@@ -4743,7 +4775,7 @@
           <a:noFill/>
         </p:spPr>
         <p:txBody>
-          <a:bodyPr wrap="square" lIns="0" rIns="0" tIns="0" bIns="0">
+          <a:bodyPr wrap="square" lIns="0" tIns="0" rIns="0" bIns="0">
             <a:spAutoFit/>
           </a:bodyPr>
           <a:lstStyle/>
@@ -4779,7 +4811,7 @@
           <a:noFill/>
         </p:spPr>
         <p:txBody>
-          <a:bodyPr wrap="square" lIns="0" rIns="0" tIns="0" bIns="0">
+          <a:bodyPr wrap="square" lIns="0" tIns="0" rIns="0" bIns="0">
             <a:spAutoFit/>
           </a:bodyPr>
           <a:lstStyle/>
@@ -4838,6 +4870,7 @@
           <a:lstStyle/>
           <a:p>
             <a:pPr algn="ctr"/>
+            <a:endParaRPr/>
           </a:p>
         </p:txBody>
       </p:sp>
@@ -4883,6 +4916,7 @@
           <a:lstStyle/>
           <a:p>
             <a:pPr algn="ctr"/>
+            <a:endParaRPr/>
           </a:p>
         </p:txBody>
       </p:sp>
@@ -4903,7 +4937,7 @@
           <a:noFill/>
         </p:spPr>
         <p:txBody>
-          <a:bodyPr wrap="square" lIns="0" tIns="0" bIns="0" rIns="0">
+          <a:bodyPr wrap="square" lIns="0" tIns="0" rIns="0" bIns="0">
             <a:spAutoFit/>
           </a:bodyPr>
           <a:lstStyle/>
@@ -5032,6 +5066,7 @@
           <a:lstStyle/>
           <a:p>
             <a:pPr algn="ctr"/>
+            <a:endParaRPr/>
           </a:p>
         </p:txBody>
       </p:sp>
@@ -5052,7 +5087,7 @@
           <a:noFill/>
         </p:spPr>
         <p:txBody>
-          <a:bodyPr wrap="square" lIns="0" tIns="0" bIns="0" rIns="0">
+          <a:bodyPr wrap="square" lIns="0" tIns="0" rIns="0" bIns="0">
             <a:spAutoFit/>
           </a:bodyPr>
           <a:lstStyle/>
@@ -5181,6 +5216,7 @@
           <a:lstStyle/>
           <a:p>
             <a:pPr algn="ctr"/>
+            <a:endParaRPr/>
           </a:p>
         </p:txBody>
       </p:sp>
@@ -5201,7 +5237,7 @@
           <a:noFill/>
         </p:spPr>
         <p:txBody>
-          <a:bodyPr wrap="square" lIns="0" tIns="0" bIns="0" rIns="0">
+          <a:bodyPr wrap="square" lIns="0" tIns="0" rIns="0" bIns="0">
             <a:spAutoFit/>
           </a:bodyPr>
           <a:lstStyle/>
@@ -5330,6 +5366,7 @@
           <a:lstStyle/>
           <a:p>
             <a:pPr algn="ctr"/>
+            <a:endParaRPr/>
           </a:p>
         </p:txBody>
       </p:sp>
@@ -5350,7 +5387,7 @@
           <a:noFill/>
         </p:spPr>
         <p:txBody>
-          <a:bodyPr wrap="square" lIns="0" tIns="0" bIns="0" rIns="0">
+          <a:bodyPr wrap="square" lIns="0" tIns="0" rIns="0" bIns="0">
             <a:spAutoFit/>
           </a:bodyPr>
           <a:lstStyle/>
@@ -5446,7 +5483,7 @@
 </file>
 
 <file path=ppt/slides/slide5.xml><?xml version="1.0" encoding="utf-8"?>
-<p:sld xmlns:a="http://schemas.openxmlformats.org/drawingml/2006/main" xmlns:p="http://schemas.openxmlformats.org/presentationml/2006/main" xmlns:r="http://schemas.openxmlformats.org/officeDocument/2006/relationships">
+<p:sld xmlns:a="http://schemas.openxmlformats.org/drawingml/2006/main" xmlns:r="http://schemas.openxmlformats.org/officeDocument/2006/relationships" xmlns:p="http://schemas.openxmlformats.org/presentationml/2006/main">
   <p:cSld>
     <p:bg>
       <p:bgPr>
@@ -5462,7 +5499,14 @@
         <p:cNvGrpSpPr/>
         <p:nvPr/>
       </p:nvGrpSpPr>
-      <p:grpSpPr/>
+      <p:grpSpPr>
+        <a:xfrm>
+          <a:off x="0" y="0"/>
+          <a:ext cx="0" cy="0"/>
+          <a:chOff x="0" y="0"/>
+          <a:chExt cx="0" cy="0"/>
+        </a:xfrm>
+      </p:grpSpPr>
       <p:sp>
         <p:nvSpPr>
           <p:cNvPr id="2" name="TextBox 1"/>
@@ -5480,7 +5524,7 @@
           <a:noFill/>
         </p:spPr>
         <p:txBody>
-          <a:bodyPr wrap="square" lIns="0" rIns="0" tIns="0" bIns="0">
+          <a:bodyPr wrap="square" lIns="0" tIns="0" rIns="0" bIns="0">
             <a:spAutoFit/>
           </a:bodyPr>
           <a:lstStyle/>
@@ -5516,7 +5560,7 @@
           <a:noFill/>
         </p:spPr>
         <p:txBody>
-          <a:bodyPr wrap="square" lIns="0" rIns="0" tIns="0" bIns="0">
+          <a:bodyPr wrap="square" lIns="0" tIns="0" rIns="0" bIns="0">
             <a:spAutoFit/>
           </a:bodyPr>
           <a:lstStyle/>
@@ -5575,6 +5619,7 @@
           <a:lstStyle/>
           <a:p>
             <a:pPr algn="ctr"/>
+            <a:endParaRPr/>
           </a:p>
         </p:txBody>
       </p:sp>
@@ -5753,6 +5798,7 @@
           <a:lstStyle/>
           <a:p>
             <a:pPr algn="ctr"/>
+            <a:endParaRPr/>
           </a:p>
         </p:txBody>
       </p:sp>
@@ -5837,6 +5883,7 @@
                 <a:latin typeface="Consolas"/>
               </a:defRPr>
             </a:pPr>
+            <a:endParaRPr/>
           </a:p>
           <a:p>
             <a:pPr>
@@ -5882,6 +5929,7 @@
                 <a:latin typeface="Consolas"/>
               </a:defRPr>
             </a:pPr>
+            <a:endParaRPr/>
           </a:p>
           <a:p>
             <a:pPr>
@@ -6007,6 +6055,7 @@
                 <a:latin typeface="Consolas"/>
               </a:defRPr>
             </a:pPr>
+            <a:endParaRPr/>
           </a:p>
           <a:p>
             <a:pPr>
@@ -6131,7 +6180,7 @@
 </file>
 
 <file path=ppt/slides/slide6.xml><?xml version="1.0" encoding="utf-8"?>
-<p:sld xmlns:a="http://schemas.openxmlformats.org/drawingml/2006/main" xmlns:p="http://schemas.openxmlformats.org/presentationml/2006/main" xmlns:r="http://schemas.openxmlformats.org/officeDocument/2006/relationships">
+<p:sld xmlns:a="http://schemas.openxmlformats.org/drawingml/2006/main" xmlns:r="http://schemas.openxmlformats.org/officeDocument/2006/relationships" xmlns:p="http://schemas.openxmlformats.org/presentationml/2006/main">
   <p:cSld>
     <p:bg>
       <p:bgPr>
@@ -6147,7 +6196,14 @@
         <p:cNvGrpSpPr/>
         <p:nvPr/>
       </p:nvGrpSpPr>
-      <p:grpSpPr/>
+      <p:grpSpPr>
+        <a:xfrm>
+          <a:off x="0" y="0"/>
+          <a:ext cx="0" cy="0"/>
+          <a:chOff x="0" y="0"/>
+          <a:chExt cx="0" cy="0"/>
+        </a:xfrm>
+      </p:grpSpPr>
       <p:sp>
         <p:nvSpPr>
           <p:cNvPr id="2" name="TextBox 1"/>
@@ -6165,7 +6221,7 @@
           <a:noFill/>
         </p:spPr>
         <p:txBody>
-          <a:bodyPr wrap="square" lIns="0" rIns="0" tIns="0" bIns="0">
+          <a:bodyPr wrap="square" lIns="0" tIns="0" rIns="0" bIns="0">
             <a:spAutoFit/>
           </a:bodyPr>
           <a:lstStyle/>
@@ -6201,7 +6257,7 @@
           <a:noFill/>
         </p:spPr>
         <p:txBody>
-          <a:bodyPr wrap="square" lIns="0" rIns="0" tIns="0" bIns="0">
+          <a:bodyPr wrap="square" lIns="0" tIns="0" rIns="0" bIns="0">
             <a:spAutoFit/>
           </a:bodyPr>
           <a:lstStyle/>
@@ -6260,6 +6316,7 @@
           <a:lstStyle/>
           <a:p>
             <a:pPr algn="ctr"/>
+            <a:endParaRPr/>
           </a:p>
         </p:txBody>
       </p:sp>
@@ -6438,6 +6495,7 @@
           <a:lstStyle/>
           <a:p>
             <a:pPr algn="ctr"/>
+            <a:endParaRPr/>
           </a:p>
         </p:txBody>
       </p:sp>
@@ -6538,6 +6596,7 @@
                 <a:latin typeface="Consolas"/>
               </a:defRPr>
             </a:pPr>
+            <a:endParaRPr/>
           </a:p>
           <a:p>
             <a:pPr>
@@ -6695,6 +6754,7 @@
                 <a:latin typeface="Consolas"/>
               </a:defRPr>
             </a:pPr>
+            <a:endParaRPr/>
           </a:p>
           <a:p>
             <a:pPr>
@@ -6772,6 +6832,7 @@
                 <a:latin typeface="Consolas"/>
               </a:defRPr>
             </a:pPr>
+            <a:endParaRPr/>
           </a:p>
           <a:p>
             <a:pPr>
@@ -6816,7 +6877,7 @@
 </file>
 
 <file path=ppt/slides/slide7.xml><?xml version="1.0" encoding="utf-8"?>
-<p:sld xmlns:a="http://schemas.openxmlformats.org/drawingml/2006/main" xmlns:p="http://schemas.openxmlformats.org/presentationml/2006/main" xmlns:r="http://schemas.openxmlformats.org/officeDocument/2006/relationships">
+<p:sld xmlns:a="http://schemas.openxmlformats.org/drawingml/2006/main" xmlns:r="http://schemas.openxmlformats.org/officeDocument/2006/relationships" xmlns:p="http://schemas.openxmlformats.org/presentationml/2006/main">
   <p:cSld>
     <p:bg>
       <p:bgPr>
@@ -6832,7 +6893,14 @@
         <p:cNvGrpSpPr/>
         <p:nvPr/>
       </p:nvGrpSpPr>
-      <p:grpSpPr/>
+      <p:grpSpPr>
+        <a:xfrm>
+          <a:off x="0" y="0"/>
+          <a:ext cx="0" cy="0"/>
+          <a:chOff x="0" y="0"/>
+          <a:chExt cx="0" cy="0"/>
+        </a:xfrm>
+      </p:grpSpPr>
       <p:sp>
         <p:nvSpPr>
           <p:cNvPr id="2" name="TextBox 1"/>
@@ -6850,7 +6918,7 @@
           <a:noFill/>
         </p:spPr>
         <p:txBody>
-          <a:bodyPr wrap="square" lIns="0" rIns="0" tIns="0" bIns="0">
+          <a:bodyPr wrap="square" lIns="0" tIns="0" rIns="0" bIns="0">
             <a:spAutoFit/>
           </a:bodyPr>
           <a:lstStyle/>
@@ -6886,7 +6954,7 @@
           <a:noFill/>
         </p:spPr>
         <p:txBody>
-          <a:bodyPr wrap="square" lIns="0" rIns="0" tIns="0" bIns="0">
+          <a:bodyPr wrap="square" lIns="0" tIns="0" rIns="0" bIns="0">
             <a:spAutoFit/>
           </a:bodyPr>
           <a:lstStyle/>
@@ -6945,6 +7013,7 @@
           <a:lstStyle/>
           <a:p>
             <a:pPr algn="ctr"/>
+            <a:endParaRPr/>
           </a:p>
         </p:txBody>
       </p:sp>
@@ -7123,6 +7192,7 @@
           <a:lstStyle/>
           <a:p>
             <a:pPr algn="ctr"/>
+            <a:endParaRPr/>
           </a:p>
         </p:txBody>
       </p:sp>
@@ -7207,6 +7277,7 @@
                 <a:latin typeface="Consolas"/>
               </a:defRPr>
             </a:pPr>
+            <a:endParaRPr/>
           </a:p>
           <a:p>
             <a:pPr>
@@ -7252,6 +7323,7 @@
                 <a:latin typeface="Consolas"/>
               </a:defRPr>
             </a:pPr>
+            <a:endParaRPr/>
           </a:p>
           <a:p>
             <a:pPr>
@@ -7329,6 +7401,7 @@
                 <a:latin typeface="Consolas"/>
               </a:defRPr>
             </a:pPr>
+            <a:endParaRPr/>
           </a:p>
           <a:p>
             <a:pPr>
@@ -7390,6 +7463,7 @@
                 <a:latin typeface="Consolas"/>
               </a:defRPr>
             </a:pPr>
+            <a:endParaRPr/>
           </a:p>
           <a:p>
             <a:pPr>
@@ -7530,7 +7604,7 @@
 </file>
 
 <file path=ppt/slides/slide8.xml><?xml version="1.0" encoding="utf-8"?>
-<p:sld xmlns:a="http://schemas.openxmlformats.org/drawingml/2006/main" xmlns:p="http://schemas.openxmlformats.org/presentationml/2006/main" xmlns:r="http://schemas.openxmlformats.org/officeDocument/2006/relationships">
+<p:sld xmlns:a="http://schemas.openxmlformats.org/drawingml/2006/main" xmlns:r="http://schemas.openxmlformats.org/officeDocument/2006/relationships" xmlns:p="http://schemas.openxmlformats.org/presentationml/2006/main">
   <p:cSld>
     <p:bg>
       <p:bgPr>
@@ -7546,7 +7620,14 @@
         <p:cNvGrpSpPr/>
         <p:nvPr/>
       </p:nvGrpSpPr>
-      <p:grpSpPr/>
+      <p:grpSpPr>
+        <a:xfrm>
+          <a:off x="0" y="0"/>
+          <a:ext cx="0" cy="0"/>
+          <a:chOff x="0" y="0"/>
+          <a:chExt cx="0" cy="0"/>
+        </a:xfrm>
+      </p:grpSpPr>
       <p:sp>
         <p:nvSpPr>
           <p:cNvPr id="2" name="TextBox 1"/>
@@ -7564,7 +7645,7 @@
           <a:noFill/>
         </p:spPr>
         <p:txBody>
-          <a:bodyPr wrap="square" lIns="0" rIns="0" tIns="0" bIns="0">
+          <a:bodyPr wrap="square" lIns="0" tIns="0" rIns="0" bIns="0">
             <a:spAutoFit/>
           </a:bodyPr>
           <a:lstStyle/>
@@ -7600,7 +7681,7 @@
           <a:noFill/>
         </p:spPr>
         <p:txBody>
-          <a:bodyPr wrap="square" lIns="0" rIns="0" tIns="0" bIns="0">
+          <a:bodyPr wrap="square" lIns="0" tIns="0" rIns="0" bIns="0">
             <a:spAutoFit/>
           </a:bodyPr>
           <a:lstStyle/>
@@ -7659,6 +7740,7 @@
           <a:lstStyle/>
           <a:p>
             <a:pPr algn="ctr"/>
+            <a:endParaRPr/>
           </a:p>
         </p:txBody>
       </p:sp>
@@ -7839,6 +7921,7 @@
           <a:lstStyle/>
           <a:p>
             <a:pPr algn="ctr"/>
+            <a:endParaRPr/>
           </a:p>
         </p:txBody>
       </p:sp>
@@ -7924,7 +8007,7 @@
 </file>
 
 <file path=ppt/slides/slide9.xml><?xml version="1.0" encoding="utf-8"?>
-<p:sld xmlns:a="http://schemas.openxmlformats.org/drawingml/2006/main" xmlns:p="http://schemas.openxmlformats.org/presentationml/2006/main" xmlns:r="http://schemas.openxmlformats.org/officeDocument/2006/relationships">
+<p:sld xmlns:a="http://schemas.openxmlformats.org/drawingml/2006/main" xmlns:r="http://schemas.openxmlformats.org/officeDocument/2006/relationships" xmlns:p="http://schemas.openxmlformats.org/presentationml/2006/main">
   <p:cSld>
     <p:bg>
       <p:bgPr>
@@ -7940,7 +8023,14 @@
         <p:cNvGrpSpPr/>
         <p:nvPr/>
       </p:nvGrpSpPr>
-      <p:grpSpPr/>
+      <p:grpSpPr>
+        <a:xfrm>
+          <a:off x="0" y="0"/>
+          <a:ext cx="0" cy="0"/>
+          <a:chOff x="0" y="0"/>
+          <a:chExt cx="0" cy="0"/>
+        </a:xfrm>
+      </p:grpSpPr>
       <p:sp>
         <p:nvSpPr>
           <p:cNvPr id="2" name="TextBox 1"/>
@@ -7958,7 +8048,7 @@
           <a:noFill/>
         </p:spPr>
         <p:txBody>
-          <a:bodyPr wrap="square" lIns="0" rIns="0" tIns="0" bIns="0">
+          <a:bodyPr wrap="square" lIns="0" tIns="0" rIns="0" bIns="0">
             <a:spAutoFit/>
           </a:bodyPr>
           <a:lstStyle/>
@@ -7994,7 +8084,7 @@
           <a:noFill/>
         </p:spPr>
         <p:txBody>
-          <a:bodyPr wrap="square" lIns="0" rIns="0" tIns="0" bIns="0">
+          <a:bodyPr wrap="square" lIns="0" tIns="0" rIns="0" bIns="0">
             <a:spAutoFit/>
           </a:bodyPr>
           <a:lstStyle/>
@@ -8053,6 +8143,7 @@
           <a:lstStyle/>
           <a:p>
             <a:pPr algn="ctr"/>
+            <a:endParaRPr/>
           </a:p>
         </p:txBody>
       </p:sp>
@@ -8098,6 +8189,7 @@
           <a:lstStyle/>
           <a:p>
             <a:pPr algn="ctr"/>
+            <a:endParaRPr/>
           </a:p>
         </p:txBody>
       </p:sp>
@@ -8118,7 +8210,7 @@
           <a:noFill/>
         </p:spPr>
         <p:txBody>
-          <a:bodyPr wrap="square" lIns="0" tIns="0" bIns="0" rIns="0">
+          <a:bodyPr wrap="square" lIns="0" tIns="0" rIns="0" bIns="0">
             <a:spAutoFit/>
           </a:bodyPr>
           <a:lstStyle/>
@@ -8195,6 +8287,7 @@
           <a:lstStyle/>
           <a:p>
             <a:pPr algn="ctr"/>
+            <a:endParaRPr/>
           </a:p>
         </p:txBody>
       </p:sp>
@@ -8215,7 +8308,7 @@
           <a:noFill/>
         </p:spPr>
         <p:txBody>
-          <a:bodyPr wrap="square" lIns="0" tIns="0" bIns="0" rIns="0">
+          <a:bodyPr wrap="square" lIns="0" tIns="0" rIns="0" bIns="0">
             <a:spAutoFit/>
           </a:bodyPr>
           <a:lstStyle/>
@@ -8292,6 +8385,7 @@
           <a:lstStyle/>
           <a:p>
             <a:pPr algn="ctr"/>
+            <a:endParaRPr/>
           </a:p>
         </p:txBody>
       </p:sp>
@@ -8312,7 +8406,7 @@
           <a:noFill/>
         </p:spPr>
         <p:txBody>
-          <a:bodyPr wrap="square" lIns="0" tIns="0" bIns="0" rIns="0">
+          <a:bodyPr wrap="square" lIns="0" tIns="0" rIns="0" bIns="0">
             <a:spAutoFit/>
           </a:bodyPr>
           <a:lstStyle/>
@@ -8389,6 +8483,7 @@
           <a:lstStyle/>
           <a:p>
             <a:pPr algn="ctr"/>
+            <a:endParaRPr/>
           </a:p>
         </p:txBody>
       </p:sp>
@@ -8409,7 +8504,7 @@
           <a:noFill/>
         </p:spPr>
         <p:txBody>
-          <a:bodyPr wrap="square" lIns="0" tIns="0" bIns="0" rIns="0">
+          <a:bodyPr wrap="square" lIns="0" tIns="0" rIns="0" bIns="0">
             <a:spAutoFit/>
           </a:bodyPr>
           <a:lstStyle/>

</xml_diff>